<commit_message>
docs: rename ADLC expansion to "Agentic Development Lifecycle"
</commit_message>
<xml_diff>
--- a/presentation/modernizing-101/Modernizing_101-r1.0.pptx
+++ b/presentation/modernizing-101/Modernizing_101-r1.0.pptx
@@ -521,7 +521,7 @@
           <a:p>
             <a:r>
               <a:rPr lang="en-US" dirty="0"/>
-              <a:t>This is the 101 — the ideas deck. It makes the conceptual case for modernization and explains the method that drives it, without going into the implementation; the running code, the service-by-service detail, and the live demos are the 201's job. The whole argument is one claim taken seriously: a coupled Spring Boot monolith can become Quarkus and Camel microservices without a big-bang rewrite and without breaking behaviour, if you move one seam at a time behind an automated behavioural gate. The migration was driven by an AI Development Lifecycle, which the second section covers. No prior Quarkus knowledge is assumed. Everything here is drawn from a real running reference system you can build and drive yourself.</a:t>
+              <a:t>This is the 101 — the ideas deck. It makes the conceptual case for modernization and explains the method that drives it, without going into the implementation; the running code, the service-by-service detail, and the live demos are the 201's job. The whole argument is one claim taken seriously: a coupled Spring Boot monolith can become Quarkus and Camel microservices without a big-bang rewrite and without breaking behaviour, if you move one seam at a time behind an automated behavioural gate. The migration was driven by an Agentic Development Lifecycle, which the second section covers. No prior Quarkus knowledge is assumed. Everything here is drawn from a real running reference system you can build and drive yourself.</a:t>
             </a:r>
             <a:endParaRPr lang="en-US" dirty="0"/>
           </a:p>
@@ -2017,7 +2017,7 @@
           <a:p>
             <a:r>
               <a:rPr lang="en-US" dirty="0"/>
-              <a:t>This is the section the original deck never had, and it is the centre of gravity for the whole approach. In the classic software lifecycle the human is the author; in the AI Development Lifecycle the human becomes the framer and the gatekeeper while the agent is the author. That reassignment is only responsible if correctness can be checked without a person reading every diff — which is why the method is built around an automated gate rather than around trust in the model. The economic driver underneath it is simple: when generating a change becomes cheap, the cost and the risk both move to verification, so that is where the method puts its weight. Hold that thought — the gate is the next two slides.</a:t>
+              <a:t>This is the section the original deck never had, and it is the centre of gravity for the whole approach. In the classic software lifecycle the human is the author; in the Agentic Development Lifecycle the human becomes the framer and the gatekeeper while the agent is the author. That reassignment is only responsible if correctness can be checked without a person reading every diff — which is why the method is built around an automated gate rather than around trust in the model. The economic driver underneath it is simple: when generating a change becomes cheap, the cost and the risk both move to verification, so that is where the method puts its weight. Hold that thought — the gate is the next two slides.</a:t>
             </a:r>
             <a:endParaRPr lang="en-US" dirty="0"/>
           </a:p>

</xml_diff>

<commit_message>
docs: rename ADLC expansion to "Agentic Development Lifecycle" (#23)
</commit_message>
<xml_diff>
--- a/presentation/modernizing-101/Modernizing_101-r1.0.pptx
+++ b/presentation/modernizing-101/Modernizing_101-r1.0.pptx
@@ -521,7 +521,7 @@
           <a:p>
             <a:r>
               <a:rPr lang="en-US" dirty="0"/>
-              <a:t>This is the 101 — the ideas deck. It makes the conceptual case for modernization and explains the method that drives it, without going into the implementation; the running code, the service-by-service detail, and the live demos are the 201's job. The whole argument is one claim taken seriously: a coupled Spring Boot monolith can become Quarkus and Camel microservices without a big-bang rewrite and without breaking behaviour, if you move one seam at a time behind an automated behavioural gate. The migration was driven by an AI Development Lifecycle, which the second section covers. No prior Quarkus knowledge is assumed. Everything here is drawn from a real running reference system you can build and drive yourself.</a:t>
+              <a:t>This is the 101 — the ideas deck. It makes the conceptual case for modernization and explains the method that drives it, without going into the implementation; the running code, the service-by-service detail, and the live demos are the 201's job. The whole argument is one claim taken seriously: a coupled Spring Boot monolith can become Quarkus and Camel microservices without a big-bang rewrite and without breaking behaviour, if you move one seam at a time behind an automated behavioural gate. The migration was driven by an Agentic Development Lifecycle, which the second section covers. No prior Quarkus knowledge is assumed. Everything here is drawn from a real running reference system you can build and drive yourself.</a:t>
             </a:r>
             <a:endParaRPr lang="en-US" dirty="0"/>
           </a:p>
@@ -2017,7 +2017,7 @@
           <a:p>
             <a:r>
               <a:rPr lang="en-US" dirty="0"/>
-              <a:t>This is the section the original deck never had, and it is the centre of gravity for the whole approach. In the classic software lifecycle the human is the author; in the AI Development Lifecycle the human becomes the framer and the gatekeeper while the agent is the author. That reassignment is only responsible if correctness can be checked without a person reading every diff — which is why the method is built around an automated gate rather than around trust in the model. The economic driver underneath it is simple: when generating a change becomes cheap, the cost and the risk both move to verification, so that is where the method puts its weight. Hold that thought — the gate is the next two slides.</a:t>
+              <a:t>This is the section the original deck never had, and it is the centre of gravity for the whole approach. In the classic software lifecycle the human is the author; in the Agentic Development Lifecycle the human becomes the framer and the gatekeeper while the agent is the author. That reassignment is only responsible if correctness can be checked without a person reading every diff — which is why the method is built around an automated gate rather than around trust in the model. The economic driver underneath it is simple: when generating a change becomes cheap, the cost and the risk both move to verification, so that is where the method puts its weight. Hold that thought — the gate is the next two slides.</a:t>
             </a:r>
             <a:endParaRPr lang="en-US" dirty="0"/>
           </a:p>

</xml_diff>

<commit_message>
feat(presentation): add "Take it with you" scan-to-explore QR slide to Modernizing decks
Left QR -> the modernizing-enterprise-applications site, right QR -> the
Workshops & Tutorials hub. Added to deck.js for all three decks (101, 201,
201-quarkus-camel) and rebuilt the pptx. New per-deck QR assets.
</commit_message>
<xml_diff>
--- a/presentation/modernizing-101/Modernizing_101-r1.0.pptx
+++ b/presentation/modernizing-101/Modernizing_101-r1.0.pptx
@@ -25,9 +25,10 @@
     <p:sldId id="273" r:id="rId19"/>
     <p:sldId id="274" r:id="rId20"/>
     <p:sldId id="275" r:id="rId21"/>
+    <p:sldId id="276" r:id="rId22"/>
   </p:sldIdLst>
   <p:notesMasterIdLst>
-    <p:notesMasterId r:id="rId22"/>
+    <p:notesMasterId r:id="rId23"/>
   </p:notesMasterIdLst>
   <p:sldSz cx="12192000" cy="6858000"/>
   <p:notesSz cx="6858000" cy="12192000"/>
@@ -1601,6 +1602,94 @@
             <a:fld id="{F7021451-1387-4CA6-816F-3879F97B5CBC}" type="slidenum">
               <a:rPr lang="en-US"/>
               <a:t>20</a:t>
+            </a:fld>
+            <a:endParaRPr lang="en-US"/>
+          </a:p>
+        </p:txBody>
+      </p:sp>
+    </p:spTree>
+    <p:extLst>
+      <p:ext uri="{BB962C8B-B14F-4D97-AF65-F5344CB8AC3E}">
+        <p14:creationId xmlns:p14="http://schemas.microsoft.com/office/powerpoint/2010/main" val="1024086991"/>
+      </p:ext>
+    </p:extLst>
+  </p:cSld>
+  <p:clrMapOvr>
+    <a:masterClrMapping/>
+  </p:clrMapOvr>
+</p:notes>
+</file>
+
+<file path=ppt/notesSlides/notesSlide21.xml><?xml version="1.0" encoding="utf-8"?>
+<p:notes xmlns:a="http://schemas.openxmlformats.org/drawingml/2006/main" xmlns:r="http://schemas.openxmlformats.org/officeDocument/2006/relationships" xmlns:p="http://schemas.openxmlformats.org/presentationml/2006/main">
+  <p:cSld>
+    <p:spTree>
+      <p:nvGrpSpPr>
+        <p:cNvPr id="1" name=""/>
+        <p:cNvGrpSpPr/>
+        <p:nvPr/>
+      </p:nvGrpSpPr>
+      <p:grpSpPr>
+        <a:xfrm>
+          <a:off x="0" y="0"/>
+          <a:ext cx="0" cy="0"/>
+          <a:chOff x="0" y="0"/>
+          <a:chExt cx="0" cy="0"/>
+        </a:xfrm>
+      </p:grpSpPr>
+      <p:sp>
+        <p:nvSpPr>
+          <p:cNvPr id="2" name="Slide Image Placeholder 1"/>
+          <p:cNvSpPr>
+            <a:spLocks noGrp="1" noRot="1" noChangeAspect="1"/>
+          </p:cNvSpPr>
+          <p:nvPr>
+            <p:ph type="sldImg"/>
+          </p:nvPr>
+        </p:nvSpPr>
+        <p:spPr/>
+      </p:sp>
+      <p:sp>
+        <p:nvSpPr>
+          <p:cNvPr id="3" name="Notes Placeholder 2"/>
+          <p:cNvSpPr>
+            <a:spLocks noGrp="1"/>
+          </p:cNvSpPr>
+          <p:nvPr>
+            <p:ph type="body" idx="1"/>
+          </p:nvPr>
+        </p:nvSpPr>
+        <p:spPr/>
+        <p:txBody>
+          <a:bodyPr/>
+          <a:lstStyle/>
+          <a:p>
+            <a:r>
+              <a:rPr lang="en-US" dirty="0"/>
+              <a:t>This is the 101 deck. The two codes take it with you: on the left, the reference implementation: the site, the runnable services, and the strangler-fig migration that decomposes the monolith step by step. On the right, the Workshops and Tutorials hub: every workshop, tutorial, and deck in the series in one place. Both are public on the Pattern Catalyst GitHub organization.</a:t>
+            </a:r>
+            <a:endParaRPr lang="en-US" dirty="0"/>
+          </a:p>
+        </p:txBody>
+      </p:sp>
+      <p:sp>
+        <p:nvSpPr>
+          <p:cNvPr id="4" name="Slide Number Placeholder 3"/>
+          <p:cNvSpPr>
+            <a:spLocks noGrp="1"/>
+          </p:cNvSpPr>
+          <p:nvPr>
+            <p:ph type="sldNum" sz="quarter" idx="10"/>
+          </p:nvPr>
+        </p:nvSpPr>
+        <p:spPr/>
+        <p:txBody>
+          <a:bodyPr/>
+          <a:lstStyle/>
+          <a:p>
+            <a:fld id="{F7021451-1387-4CA6-816F-3879F97B5CBC}" type="slidenum">
+              <a:rPr lang="en-US"/>
+              <a:t>21</a:t>
             </a:fld>
             <a:endParaRPr lang="en-US"/>
           </a:p>
@@ -6955,6 +7044,454 @@
 </p:sld>
 </file>
 
+<file path=ppt/slides/slide21.xml><?xml version="1.0" encoding="utf-8"?>
+<p:sld xmlns:a="http://schemas.openxmlformats.org/drawingml/2006/main" xmlns:r="http://schemas.openxmlformats.org/officeDocument/2006/relationships" xmlns:p="http://schemas.openxmlformats.org/presentationml/2006/main">
+  <p:cSld name="Slide 21">
+    <p:spTree>
+      <p:nvGrpSpPr>
+        <p:cNvPr id="1" name=""/>
+        <p:cNvGrpSpPr/>
+        <p:nvPr/>
+      </p:nvGrpSpPr>
+      <p:grpSpPr>
+        <a:xfrm>
+          <a:off x="0" y="0"/>
+          <a:ext cx="0" cy="0"/>
+          <a:chOff x="0" y="0"/>
+          <a:chExt cx="0" cy="0"/>
+        </a:xfrm>
+      </p:grpSpPr>
+      <p:sp>
+        <p:nvSpPr>
+          <p:cNvPr id="2" name="Text 0"/>
+          <p:cNvSpPr/>
+          <p:nvPr/>
+        </p:nvSpPr>
+        <p:spPr>
+          <a:xfrm>
+            <a:off x="566928" y="6364224"/>
+            <a:ext cx="914400" cy="274320"/>
+          </a:xfrm>
+          <a:prstGeom prst="rect">
+            <a:avLst/>
+          </a:prstGeom>
+          <a:noFill/>
+          <a:ln/>
+        </p:spPr>
+        <p:txBody>
+          <a:bodyPr wrap="square" rtlCol="0" anchor="ctr"/>
+          <a:lstStyle/>
+          <a:p>
+            <a:pPr algn="l" indent="0" marL="0">
+              <a:buNone/>
+            </a:pPr>
+            <a:r>
+              <a:rPr lang="en-US" sz="1000" dirty="0">
+                <a:solidFill>
+                  <a:srgbClr val="8A8A8A"/>
+                </a:solidFill>
+                <a:latin typeface="Red Hat Text" pitchFamily="34" charset="0"/>
+                <a:ea typeface="Red Hat Text" pitchFamily="34" charset="-122"/>
+                <a:cs typeface="Red Hat Text" pitchFamily="34" charset="-120"/>
+              </a:rPr>
+              <a:t>21</a:t>
+            </a:r>
+            <a:endParaRPr lang="en-US" sz="1000" dirty="0"/>
+          </a:p>
+        </p:txBody>
+      </p:sp>
+      <p:pic>
+        <p:nvPicPr>
+          <p:cNvPr id="3" name="Image 0" descr="./assets/logo-candidate-2.png">    </p:cNvPr>
+          <p:cNvPicPr>
+            <a:picLocks noChangeAspect="1"/>
+          </p:cNvPicPr>
+          <p:nvPr/>
+        </p:nvPicPr>
+        <p:blipFill>
+          <a:blip r:embed="rId1"/>
+          <a:stretch>
+            <a:fillRect/>
+          </a:stretch>
+        </p:blipFill>
+        <p:spPr>
+          <a:xfrm>
+            <a:off x="10561320" y="6355080"/>
+            <a:ext cx="1033272" cy="246888"/>
+          </a:xfrm>
+          <a:prstGeom prst="rect">
+            <a:avLst/>
+          </a:prstGeom>
+        </p:spPr>
+      </p:pic>
+      <p:sp>
+        <p:nvSpPr>
+          <p:cNvPr id="4" name="Text 1"/>
+          <p:cNvSpPr/>
+          <p:nvPr/>
+        </p:nvSpPr>
+        <p:spPr>
+          <a:xfrm>
+            <a:off x="566928" y="384048"/>
+            <a:ext cx="11055096" cy="292608"/>
+          </a:xfrm>
+          <a:prstGeom prst="rect">
+            <a:avLst/>
+          </a:prstGeom>
+          <a:noFill/>
+          <a:ln/>
+        </p:spPr>
+        <p:txBody>
+          <a:bodyPr wrap="square" rtlCol="0" anchor="ctr"/>
+          <a:lstStyle/>
+          <a:p>
+            <a:pPr algn="l" indent="0" marL="0">
+              <a:buNone/>
+            </a:pPr>
+            <a:r>
+              <a:rPr lang="en-US" sz="1200" b="1" spc="400" kern="0" dirty="0">
+                <a:solidFill>
+                  <a:srgbClr val="EE0000"/>
+                </a:solidFill>
+                <a:latin typeface="Overpass" pitchFamily="34" charset="0"/>
+                <a:ea typeface="Overpass" pitchFamily="34" charset="-122"/>
+                <a:cs typeface="Overpass" pitchFamily="34" charset="-120"/>
+              </a:rPr>
+              <a:t>SCAN TO EXPLORE</a:t>
+            </a:r>
+            <a:endParaRPr lang="en-US" sz="1200" dirty="0"/>
+          </a:p>
+        </p:txBody>
+      </p:sp>
+      <p:sp>
+        <p:nvSpPr>
+          <p:cNvPr id="5" name="Text 2"/>
+          <p:cNvSpPr/>
+          <p:nvPr/>
+        </p:nvSpPr>
+        <p:spPr>
+          <a:xfrm>
+            <a:off x="566928" y="676656"/>
+            <a:ext cx="11055096" cy="1005840"/>
+          </a:xfrm>
+          <a:prstGeom prst="rect">
+            <a:avLst/>
+          </a:prstGeom>
+          <a:noFill/>
+          <a:ln/>
+        </p:spPr>
+        <p:txBody>
+          <a:bodyPr wrap="square" rtlCol="0" anchor="t"/>
+          <a:lstStyle/>
+          <a:p>
+            <a:pPr algn="l" indent="0" marL="0">
+              <a:buNone/>
+            </a:pPr>
+            <a:r>
+              <a:rPr lang="en-US" sz="3000" b="1" dirty="0">
+                <a:solidFill>
+                  <a:srgbClr val="151515"/>
+                </a:solidFill>
+                <a:latin typeface="Overpass" pitchFamily="34" charset="0"/>
+                <a:ea typeface="Overpass" pitchFamily="34" charset="-122"/>
+                <a:cs typeface="Overpass" pitchFamily="34" charset="-120"/>
+              </a:rPr>
+              <a:t>Take it with you</a:t>
+            </a:r>
+            <a:endParaRPr lang="en-US" sz="3000" dirty="0"/>
+          </a:p>
+        </p:txBody>
+      </p:sp>
+      <p:pic>
+        <p:nvPicPr>
+          <p:cNvPr id="6" name="Image 1" descr="./assets/qr-modernizing-site.png">    </p:cNvPr>
+          <p:cNvPicPr>
+            <a:picLocks noChangeAspect="1"/>
+          </p:cNvPicPr>
+          <p:nvPr/>
+        </p:nvPicPr>
+        <p:blipFill>
+          <a:blip r:embed="rId2"/>
+          <a:stretch>
+            <a:fillRect/>
+          </a:stretch>
+        </p:blipFill>
+        <p:spPr>
+          <a:xfrm>
+            <a:off x="2103120" y="1627632"/>
+            <a:ext cx="2834640" cy="2834640"/>
+          </a:xfrm>
+          <a:prstGeom prst="rect">
+            <a:avLst/>
+          </a:prstGeom>
+        </p:spPr>
+      </p:pic>
+      <p:sp>
+        <p:nvSpPr>
+          <p:cNvPr id="7" name="Text 3"/>
+          <p:cNvSpPr/>
+          <p:nvPr/>
+        </p:nvSpPr>
+        <p:spPr>
+          <a:xfrm>
+            <a:off x="1417320" y="4553712"/>
+            <a:ext cx="4206240" cy="365760"/>
+          </a:xfrm>
+          <a:prstGeom prst="rect">
+            <a:avLst/>
+          </a:prstGeom>
+          <a:noFill/>
+          <a:ln/>
+        </p:spPr>
+        <p:txBody>
+          <a:bodyPr wrap="square" rtlCol="0" anchor="ctr"/>
+          <a:lstStyle/>
+          <a:p>
+            <a:pPr algn="ctr" indent="0" marL="0">
+              <a:buNone/>
+            </a:pPr>
+            <a:r>
+              <a:rPr lang="en-US" sz="1800" b="1" dirty="0">
+                <a:solidFill>
+                  <a:srgbClr val="151515"/>
+                </a:solidFill>
+                <a:latin typeface="Overpass" pitchFamily="34" charset="0"/>
+                <a:ea typeface="Overpass" pitchFamily="34" charset="-122"/>
+                <a:cs typeface="Overpass" pitchFamily="34" charset="-120"/>
+              </a:rPr>
+              <a:t>The reference implementation</a:t>
+            </a:r>
+            <a:endParaRPr lang="en-US" sz="1800" dirty="0"/>
+          </a:p>
+        </p:txBody>
+      </p:sp>
+      <p:sp>
+        <p:nvSpPr>
+          <p:cNvPr id="8" name="Text 4"/>
+          <p:cNvSpPr/>
+          <p:nvPr/>
+        </p:nvSpPr>
+        <p:spPr>
+          <a:xfrm>
+            <a:off x="1325880" y="4937760"/>
+            <a:ext cx="4389120" cy="658368"/>
+          </a:xfrm>
+          <a:prstGeom prst="rect">
+            <a:avLst/>
+          </a:prstGeom>
+          <a:noFill/>
+          <a:ln/>
+        </p:spPr>
+        <p:txBody>
+          <a:bodyPr wrap="square" rtlCol="0" anchor="t"/>
+          <a:lstStyle/>
+          <a:p>
+            <a:pPr algn="ctr" indent="0" marL="0">
+              <a:buNone/>
+            </a:pPr>
+            <a:r>
+              <a:rPr lang="en-US" sz="1300" i="1" dirty="0">
+                <a:solidFill>
+                  <a:srgbClr val="5A5A5A"/>
+                </a:solidFill>
+                <a:latin typeface="Red Hat Text" pitchFamily="34" charset="0"/>
+                <a:ea typeface="Red Hat Text" pitchFamily="34" charset="-122"/>
+                <a:cs typeface="Red Hat Text" pitchFamily="34" charset="-120"/>
+              </a:rPr>
+              <a:t>Site, runnable services, and the strangler-fig migration</a:t>
+            </a:r>
+            <a:endParaRPr lang="en-US" sz="1300" dirty="0"/>
+          </a:p>
+        </p:txBody>
+      </p:sp>
+      <p:sp>
+        <p:nvSpPr>
+          <p:cNvPr id="9" name="Text 5"/>
+          <p:cNvSpPr/>
+          <p:nvPr/>
+        </p:nvSpPr>
+        <p:spPr>
+          <a:xfrm>
+            <a:off x="1325880" y="5596128"/>
+            <a:ext cx="4389120" cy="292608"/>
+          </a:xfrm>
+          <a:prstGeom prst="rect">
+            <a:avLst/>
+          </a:prstGeom>
+          <a:noFill/>
+          <a:ln/>
+        </p:spPr>
+        <p:txBody>
+          <a:bodyPr wrap="square" rtlCol="0" anchor="ctr"/>
+          <a:lstStyle/>
+          <a:p>
+            <a:pPr algn="ctr" indent="0" marL="0">
+              <a:buNone/>
+            </a:pPr>
+            <a:r>
+              <a:rPr lang="en-US" sz="1000" dirty="0">
+                <a:solidFill>
+                  <a:srgbClr val="EE0000"/>
+                </a:solidFill>
+                <a:latin typeface="Red Hat Mono" pitchFamily="34" charset="0"/>
+                <a:ea typeface="Red Hat Mono" pitchFamily="34" charset="-122"/>
+                <a:cs typeface="Red Hat Mono" pitchFamily="34" charset="-120"/>
+              </a:rPr>
+              <a:t>patterncatalyst.github.io/modernizing-enterprise-applications</a:t>
+            </a:r>
+            <a:endParaRPr lang="en-US" sz="1000" dirty="0"/>
+          </a:p>
+        </p:txBody>
+      </p:sp>
+      <p:pic>
+        <p:nvPicPr>
+          <p:cNvPr id="10" name="Image 2" descr="./assets/qr-hub.png">    </p:cNvPr>
+          <p:cNvPicPr>
+            <a:picLocks noChangeAspect="1"/>
+          </p:cNvPicPr>
+          <p:nvPr/>
+        </p:nvPicPr>
+        <p:blipFill>
+          <a:blip r:embed="rId3"/>
+          <a:stretch>
+            <a:fillRect/>
+          </a:stretch>
+        </p:blipFill>
+        <p:spPr>
+          <a:xfrm>
+            <a:off x="7251192" y="1627632"/>
+            <a:ext cx="2834640" cy="2834640"/>
+          </a:xfrm>
+          <a:prstGeom prst="rect">
+            <a:avLst/>
+          </a:prstGeom>
+        </p:spPr>
+      </p:pic>
+      <p:sp>
+        <p:nvSpPr>
+          <p:cNvPr id="11" name="Text 6"/>
+          <p:cNvSpPr/>
+          <p:nvPr/>
+        </p:nvSpPr>
+        <p:spPr>
+          <a:xfrm>
+            <a:off x="6565392" y="4553712"/>
+            <a:ext cx="4206240" cy="365760"/>
+          </a:xfrm>
+          <a:prstGeom prst="rect">
+            <a:avLst/>
+          </a:prstGeom>
+          <a:noFill/>
+          <a:ln/>
+        </p:spPr>
+        <p:txBody>
+          <a:bodyPr wrap="square" rtlCol="0" anchor="ctr"/>
+          <a:lstStyle/>
+          <a:p>
+            <a:pPr algn="ctr" indent="0" marL="0">
+              <a:buNone/>
+            </a:pPr>
+            <a:r>
+              <a:rPr lang="en-US" sz="1800" b="1" dirty="0">
+                <a:solidFill>
+                  <a:srgbClr val="151515"/>
+                </a:solidFill>
+                <a:latin typeface="Overpass" pitchFamily="34" charset="0"/>
+                <a:ea typeface="Overpass" pitchFamily="34" charset="-122"/>
+                <a:cs typeface="Overpass" pitchFamily="34" charset="-120"/>
+              </a:rPr>
+              <a:t>Workshops &amp; Tutorials</a:t>
+            </a:r>
+            <a:endParaRPr lang="en-US" sz="1800" dirty="0"/>
+          </a:p>
+        </p:txBody>
+      </p:sp>
+      <p:sp>
+        <p:nvSpPr>
+          <p:cNvPr id="12" name="Text 7"/>
+          <p:cNvSpPr/>
+          <p:nvPr/>
+        </p:nvSpPr>
+        <p:spPr>
+          <a:xfrm>
+            <a:off x="6473952" y="4937760"/>
+            <a:ext cx="4389120" cy="658368"/>
+          </a:xfrm>
+          <a:prstGeom prst="rect">
+            <a:avLst/>
+          </a:prstGeom>
+          <a:noFill/>
+          <a:ln/>
+        </p:spPr>
+        <p:txBody>
+          <a:bodyPr wrap="square" rtlCol="0" anchor="t"/>
+          <a:lstStyle/>
+          <a:p>
+            <a:pPr algn="ctr" indent="0" marL="0">
+              <a:buNone/>
+            </a:pPr>
+            <a:r>
+              <a:rPr lang="en-US" sz="1300" i="1" dirty="0">
+                <a:solidFill>
+                  <a:srgbClr val="5A5A5A"/>
+                </a:solidFill>
+                <a:latin typeface="Red Hat Text" pitchFamily="34" charset="0"/>
+                <a:ea typeface="Red Hat Text" pitchFamily="34" charset="-122"/>
+                <a:cs typeface="Red Hat Text" pitchFamily="34" charset="-120"/>
+              </a:rPr>
+              <a:t>The whole series: every workshop, tutorial, and deck in one place</a:t>
+            </a:r>
+            <a:endParaRPr lang="en-US" sz="1300" dirty="0"/>
+          </a:p>
+        </p:txBody>
+      </p:sp>
+      <p:sp>
+        <p:nvSpPr>
+          <p:cNvPr id="13" name="Text 8"/>
+          <p:cNvSpPr/>
+          <p:nvPr/>
+        </p:nvSpPr>
+        <p:spPr>
+          <a:xfrm>
+            <a:off x="6473952" y="5596128"/>
+            <a:ext cx="4389120" cy="292608"/>
+          </a:xfrm>
+          <a:prstGeom prst="rect">
+            <a:avLst/>
+          </a:prstGeom>
+          <a:noFill/>
+          <a:ln/>
+        </p:spPr>
+        <p:txBody>
+          <a:bodyPr wrap="square" rtlCol="0" anchor="ctr"/>
+          <a:lstStyle/>
+          <a:p>
+            <a:pPr algn="ctr" indent="0" marL="0">
+              <a:buNone/>
+            </a:pPr>
+            <a:r>
+              <a:rPr lang="en-US" sz="900" dirty="0">
+                <a:solidFill>
+                  <a:srgbClr val="EE0000"/>
+                </a:solidFill>
+                <a:latin typeface="Red Hat Mono" pitchFamily="34" charset="0"/>
+                <a:ea typeface="Red Hat Mono" pitchFamily="34" charset="-122"/>
+                <a:cs typeface="Red Hat Mono" pitchFamily="34" charset="-120"/>
+              </a:rPr>
+              <a:t>patterncatalyst.github.io/patterncatalyst-workshops-tutorials-list</a:t>
+            </a:r>
+            <a:endParaRPr lang="en-US" sz="900" dirty="0"/>
+          </a:p>
+        </p:txBody>
+      </p:sp>
+    </p:spTree>
+  </p:cSld>
+  <p:clrMapOvr>
+    <a:masterClrMapping/>
+  </p:clrMapOvr>
+</p:sld>
+</file>
+
 <file path=ppt/slides/slide3.xml><?xml version="1.0" encoding="utf-8"?>
 <p:sld xmlns:a="http://schemas.openxmlformats.org/drawingml/2006/main" xmlns:r="http://schemas.openxmlformats.org/officeDocument/2006/relationships" xmlns:p="http://schemas.openxmlformats.org/presentationml/2006/main">
   <p:cSld name="Slide 3">

</xml_diff>

<commit_message>
feat(presentation): add "Take it with you" scan-to-explore QR slide to Modernizing decks (#24)
Left QR -> the modernizing-enterprise-applications site, right QR -> the
Workshops & Tutorials hub. Added to deck.js for all three decks (101, 201,
201-quarkus-camel) and rebuilt the pptx. New per-deck QR assets.
</commit_message>
<xml_diff>
--- a/presentation/modernizing-101/Modernizing_101-r1.0.pptx
+++ b/presentation/modernizing-101/Modernizing_101-r1.0.pptx
@@ -25,9 +25,10 @@
     <p:sldId id="273" r:id="rId19"/>
     <p:sldId id="274" r:id="rId20"/>
     <p:sldId id="275" r:id="rId21"/>
+    <p:sldId id="276" r:id="rId22"/>
   </p:sldIdLst>
   <p:notesMasterIdLst>
-    <p:notesMasterId r:id="rId22"/>
+    <p:notesMasterId r:id="rId23"/>
   </p:notesMasterIdLst>
   <p:sldSz cx="12192000" cy="6858000"/>
   <p:notesSz cx="6858000" cy="12192000"/>
@@ -1601,6 +1602,94 @@
             <a:fld id="{F7021451-1387-4CA6-816F-3879F97B5CBC}" type="slidenum">
               <a:rPr lang="en-US"/>
               <a:t>20</a:t>
+            </a:fld>
+            <a:endParaRPr lang="en-US"/>
+          </a:p>
+        </p:txBody>
+      </p:sp>
+    </p:spTree>
+    <p:extLst>
+      <p:ext uri="{BB962C8B-B14F-4D97-AF65-F5344CB8AC3E}">
+        <p14:creationId xmlns:p14="http://schemas.microsoft.com/office/powerpoint/2010/main" val="1024086991"/>
+      </p:ext>
+    </p:extLst>
+  </p:cSld>
+  <p:clrMapOvr>
+    <a:masterClrMapping/>
+  </p:clrMapOvr>
+</p:notes>
+</file>
+
+<file path=ppt/notesSlides/notesSlide21.xml><?xml version="1.0" encoding="utf-8"?>
+<p:notes xmlns:a="http://schemas.openxmlformats.org/drawingml/2006/main" xmlns:r="http://schemas.openxmlformats.org/officeDocument/2006/relationships" xmlns:p="http://schemas.openxmlformats.org/presentationml/2006/main">
+  <p:cSld>
+    <p:spTree>
+      <p:nvGrpSpPr>
+        <p:cNvPr id="1" name=""/>
+        <p:cNvGrpSpPr/>
+        <p:nvPr/>
+      </p:nvGrpSpPr>
+      <p:grpSpPr>
+        <a:xfrm>
+          <a:off x="0" y="0"/>
+          <a:ext cx="0" cy="0"/>
+          <a:chOff x="0" y="0"/>
+          <a:chExt cx="0" cy="0"/>
+        </a:xfrm>
+      </p:grpSpPr>
+      <p:sp>
+        <p:nvSpPr>
+          <p:cNvPr id="2" name="Slide Image Placeholder 1"/>
+          <p:cNvSpPr>
+            <a:spLocks noGrp="1" noRot="1" noChangeAspect="1"/>
+          </p:cNvSpPr>
+          <p:nvPr>
+            <p:ph type="sldImg"/>
+          </p:nvPr>
+        </p:nvSpPr>
+        <p:spPr/>
+      </p:sp>
+      <p:sp>
+        <p:nvSpPr>
+          <p:cNvPr id="3" name="Notes Placeholder 2"/>
+          <p:cNvSpPr>
+            <a:spLocks noGrp="1"/>
+          </p:cNvSpPr>
+          <p:nvPr>
+            <p:ph type="body" idx="1"/>
+          </p:nvPr>
+        </p:nvSpPr>
+        <p:spPr/>
+        <p:txBody>
+          <a:bodyPr/>
+          <a:lstStyle/>
+          <a:p>
+            <a:r>
+              <a:rPr lang="en-US" dirty="0"/>
+              <a:t>This is the 101 deck. The two codes take it with you: on the left, the reference implementation: the site, the runnable services, and the strangler-fig migration that decomposes the monolith step by step. On the right, the Workshops and Tutorials hub: every workshop, tutorial, and deck in the series in one place. Both are public on the Pattern Catalyst GitHub organization.</a:t>
+            </a:r>
+            <a:endParaRPr lang="en-US" dirty="0"/>
+          </a:p>
+        </p:txBody>
+      </p:sp>
+      <p:sp>
+        <p:nvSpPr>
+          <p:cNvPr id="4" name="Slide Number Placeholder 3"/>
+          <p:cNvSpPr>
+            <a:spLocks noGrp="1"/>
+          </p:cNvSpPr>
+          <p:nvPr>
+            <p:ph type="sldNum" sz="quarter" idx="10"/>
+          </p:nvPr>
+        </p:nvSpPr>
+        <p:spPr/>
+        <p:txBody>
+          <a:bodyPr/>
+          <a:lstStyle/>
+          <a:p>
+            <a:fld id="{F7021451-1387-4CA6-816F-3879F97B5CBC}" type="slidenum">
+              <a:rPr lang="en-US"/>
+              <a:t>21</a:t>
             </a:fld>
             <a:endParaRPr lang="en-US"/>
           </a:p>
@@ -6955,6 +7044,454 @@
 </p:sld>
 </file>
 
+<file path=ppt/slides/slide21.xml><?xml version="1.0" encoding="utf-8"?>
+<p:sld xmlns:a="http://schemas.openxmlformats.org/drawingml/2006/main" xmlns:r="http://schemas.openxmlformats.org/officeDocument/2006/relationships" xmlns:p="http://schemas.openxmlformats.org/presentationml/2006/main">
+  <p:cSld name="Slide 21">
+    <p:spTree>
+      <p:nvGrpSpPr>
+        <p:cNvPr id="1" name=""/>
+        <p:cNvGrpSpPr/>
+        <p:nvPr/>
+      </p:nvGrpSpPr>
+      <p:grpSpPr>
+        <a:xfrm>
+          <a:off x="0" y="0"/>
+          <a:ext cx="0" cy="0"/>
+          <a:chOff x="0" y="0"/>
+          <a:chExt cx="0" cy="0"/>
+        </a:xfrm>
+      </p:grpSpPr>
+      <p:sp>
+        <p:nvSpPr>
+          <p:cNvPr id="2" name="Text 0"/>
+          <p:cNvSpPr/>
+          <p:nvPr/>
+        </p:nvSpPr>
+        <p:spPr>
+          <a:xfrm>
+            <a:off x="566928" y="6364224"/>
+            <a:ext cx="914400" cy="274320"/>
+          </a:xfrm>
+          <a:prstGeom prst="rect">
+            <a:avLst/>
+          </a:prstGeom>
+          <a:noFill/>
+          <a:ln/>
+        </p:spPr>
+        <p:txBody>
+          <a:bodyPr wrap="square" rtlCol="0" anchor="ctr"/>
+          <a:lstStyle/>
+          <a:p>
+            <a:pPr algn="l" indent="0" marL="0">
+              <a:buNone/>
+            </a:pPr>
+            <a:r>
+              <a:rPr lang="en-US" sz="1000" dirty="0">
+                <a:solidFill>
+                  <a:srgbClr val="8A8A8A"/>
+                </a:solidFill>
+                <a:latin typeface="Red Hat Text" pitchFamily="34" charset="0"/>
+                <a:ea typeface="Red Hat Text" pitchFamily="34" charset="-122"/>
+                <a:cs typeface="Red Hat Text" pitchFamily="34" charset="-120"/>
+              </a:rPr>
+              <a:t>21</a:t>
+            </a:r>
+            <a:endParaRPr lang="en-US" sz="1000" dirty="0"/>
+          </a:p>
+        </p:txBody>
+      </p:sp>
+      <p:pic>
+        <p:nvPicPr>
+          <p:cNvPr id="3" name="Image 0" descr="./assets/logo-candidate-2.png">    </p:cNvPr>
+          <p:cNvPicPr>
+            <a:picLocks noChangeAspect="1"/>
+          </p:cNvPicPr>
+          <p:nvPr/>
+        </p:nvPicPr>
+        <p:blipFill>
+          <a:blip r:embed="rId1"/>
+          <a:stretch>
+            <a:fillRect/>
+          </a:stretch>
+        </p:blipFill>
+        <p:spPr>
+          <a:xfrm>
+            <a:off x="10561320" y="6355080"/>
+            <a:ext cx="1033272" cy="246888"/>
+          </a:xfrm>
+          <a:prstGeom prst="rect">
+            <a:avLst/>
+          </a:prstGeom>
+        </p:spPr>
+      </p:pic>
+      <p:sp>
+        <p:nvSpPr>
+          <p:cNvPr id="4" name="Text 1"/>
+          <p:cNvSpPr/>
+          <p:nvPr/>
+        </p:nvSpPr>
+        <p:spPr>
+          <a:xfrm>
+            <a:off x="566928" y="384048"/>
+            <a:ext cx="11055096" cy="292608"/>
+          </a:xfrm>
+          <a:prstGeom prst="rect">
+            <a:avLst/>
+          </a:prstGeom>
+          <a:noFill/>
+          <a:ln/>
+        </p:spPr>
+        <p:txBody>
+          <a:bodyPr wrap="square" rtlCol="0" anchor="ctr"/>
+          <a:lstStyle/>
+          <a:p>
+            <a:pPr algn="l" indent="0" marL="0">
+              <a:buNone/>
+            </a:pPr>
+            <a:r>
+              <a:rPr lang="en-US" sz="1200" b="1" spc="400" kern="0" dirty="0">
+                <a:solidFill>
+                  <a:srgbClr val="EE0000"/>
+                </a:solidFill>
+                <a:latin typeface="Overpass" pitchFamily="34" charset="0"/>
+                <a:ea typeface="Overpass" pitchFamily="34" charset="-122"/>
+                <a:cs typeface="Overpass" pitchFamily="34" charset="-120"/>
+              </a:rPr>
+              <a:t>SCAN TO EXPLORE</a:t>
+            </a:r>
+            <a:endParaRPr lang="en-US" sz="1200" dirty="0"/>
+          </a:p>
+        </p:txBody>
+      </p:sp>
+      <p:sp>
+        <p:nvSpPr>
+          <p:cNvPr id="5" name="Text 2"/>
+          <p:cNvSpPr/>
+          <p:nvPr/>
+        </p:nvSpPr>
+        <p:spPr>
+          <a:xfrm>
+            <a:off x="566928" y="676656"/>
+            <a:ext cx="11055096" cy="1005840"/>
+          </a:xfrm>
+          <a:prstGeom prst="rect">
+            <a:avLst/>
+          </a:prstGeom>
+          <a:noFill/>
+          <a:ln/>
+        </p:spPr>
+        <p:txBody>
+          <a:bodyPr wrap="square" rtlCol="0" anchor="t"/>
+          <a:lstStyle/>
+          <a:p>
+            <a:pPr algn="l" indent="0" marL="0">
+              <a:buNone/>
+            </a:pPr>
+            <a:r>
+              <a:rPr lang="en-US" sz="3000" b="1" dirty="0">
+                <a:solidFill>
+                  <a:srgbClr val="151515"/>
+                </a:solidFill>
+                <a:latin typeface="Overpass" pitchFamily="34" charset="0"/>
+                <a:ea typeface="Overpass" pitchFamily="34" charset="-122"/>
+                <a:cs typeface="Overpass" pitchFamily="34" charset="-120"/>
+              </a:rPr>
+              <a:t>Take it with you</a:t>
+            </a:r>
+            <a:endParaRPr lang="en-US" sz="3000" dirty="0"/>
+          </a:p>
+        </p:txBody>
+      </p:sp>
+      <p:pic>
+        <p:nvPicPr>
+          <p:cNvPr id="6" name="Image 1" descr="./assets/qr-modernizing-site.png">    </p:cNvPr>
+          <p:cNvPicPr>
+            <a:picLocks noChangeAspect="1"/>
+          </p:cNvPicPr>
+          <p:nvPr/>
+        </p:nvPicPr>
+        <p:blipFill>
+          <a:blip r:embed="rId2"/>
+          <a:stretch>
+            <a:fillRect/>
+          </a:stretch>
+        </p:blipFill>
+        <p:spPr>
+          <a:xfrm>
+            <a:off x="2103120" y="1627632"/>
+            <a:ext cx="2834640" cy="2834640"/>
+          </a:xfrm>
+          <a:prstGeom prst="rect">
+            <a:avLst/>
+          </a:prstGeom>
+        </p:spPr>
+      </p:pic>
+      <p:sp>
+        <p:nvSpPr>
+          <p:cNvPr id="7" name="Text 3"/>
+          <p:cNvSpPr/>
+          <p:nvPr/>
+        </p:nvSpPr>
+        <p:spPr>
+          <a:xfrm>
+            <a:off x="1417320" y="4553712"/>
+            <a:ext cx="4206240" cy="365760"/>
+          </a:xfrm>
+          <a:prstGeom prst="rect">
+            <a:avLst/>
+          </a:prstGeom>
+          <a:noFill/>
+          <a:ln/>
+        </p:spPr>
+        <p:txBody>
+          <a:bodyPr wrap="square" rtlCol="0" anchor="ctr"/>
+          <a:lstStyle/>
+          <a:p>
+            <a:pPr algn="ctr" indent="0" marL="0">
+              <a:buNone/>
+            </a:pPr>
+            <a:r>
+              <a:rPr lang="en-US" sz="1800" b="1" dirty="0">
+                <a:solidFill>
+                  <a:srgbClr val="151515"/>
+                </a:solidFill>
+                <a:latin typeface="Overpass" pitchFamily="34" charset="0"/>
+                <a:ea typeface="Overpass" pitchFamily="34" charset="-122"/>
+                <a:cs typeface="Overpass" pitchFamily="34" charset="-120"/>
+              </a:rPr>
+              <a:t>The reference implementation</a:t>
+            </a:r>
+            <a:endParaRPr lang="en-US" sz="1800" dirty="0"/>
+          </a:p>
+        </p:txBody>
+      </p:sp>
+      <p:sp>
+        <p:nvSpPr>
+          <p:cNvPr id="8" name="Text 4"/>
+          <p:cNvSpPr/>
+          <p:nvPr/>
+        </p:nvSpPr>
+        <p:spPr>
+          <a:xfrm>
+            <a:off x="1325880" y="4937760"/>
+            <a:ext cx="4389120" cy="658368"/>
+          </a:xfrm>
+          <a:prstGeom prst="rect">
+            <a:avLst/>
+          </a:prstGeom>
+          <a:noFill/>
+          <a:ln/>
+        </p:spPr>
+        <p:txBody>
+          <a:bodyPr wrap="square" rtlCol="0" anchor="t"/>
+          <a:lstStyle/>
+          <a:p>
+            <a:pPr algn="ctr" indent="0" marL="0">
+              <a:buNone/>
+            </a:pPr>
+            <a:r>
+              <a:rPr lang="en-US" sz="1300" i="1" dirty="0">
+                <a:solidFill>
+                  <a:srgbClr val="5A5A5A"/>
+                </a:solidFill>
+                <a:latin typeface="Red Hat Text" pitchFamily="34" charset="0"/>
+                <a:ea typeface="Red Hat Text" pitchFamily="34" charset="-122"/>
+                <a:cs typeface="Red Hat Text" pitchFamily="34" charset="-120"/>
+              </a:rPr>
+              <a:t>Site, runnable services, and the strangler-fig migration</a:t>
+            </a:r>
+            <a:endParaRPr lang="en-US" sz="1300" dirty="0"/>
+          </a:p>
+        </p:txBody>
+      </p:sp>
+      <p:sp>
+        <p:nvSpPr>
+          <p:cNvPr id="9" name="Text 5"/>
+          <p:cNvSpPr/>
+          <p:nvPr/>
+        </p:nvSpPr>
+        <p:spPr>
+          <a:xfrm>
+            <a:off x="1325880" y="5596128"/>
+            <a:ext cx="4389120" cy="292608"/>
+          </a:xfrm>
+          <a:prstGeom prst="rect">
+            <a:avLst/>
+          </a:prstGeom>
+          <a:noFill/>
+          <a:ln/>
+        </p:spPr>
+        <p:txBody>
+          <a:bodyPr wrap="square" rtlCol="0" anchor="ctr"/>
+          <a:lstStyle/>
+          <a:p>
+            <a:pPr algn="ctr" indent="0" marL="0">
+              <a:buNone/>
+            </a:pPr>
+            <a:r>
+              <a:rPr lang="en-US" sz="1000" dirty="0">
+                <a:solidFill>
+                  <a:srgbClr val="EE0000"/>
+                </a:solidFill>
+                <a:latin typeface="Red Hat Mono" pitchFamily="34" charset="0"/>
+                <a:ea typeface="Red Hat Mono" pitchFamily="34" charset="-122"/>
+                <a:cs typeface="Red Hat Mono" pitchFamily="34" charset="-120"/>
+              </a:rPr>
+              <a:t>patterncatalyst.github.io/modernizing-enterprise-applications</a:t>
+            </a:r>
+            <a:endParaRPr lang="en-US" sz="1000" dirty="0"/>
+          </a:p>
+        </p:txBody>
+      </p:sp>
+      <p:pic>
+        <p:nvPicPr>
+          <p:cNvPr id="10" name="Image 2" descr="./assets/qr-hub.png">    </p:cNvPr>
+          <p:cNvPicPr>
+            <a:picLocks noChangeAspect="1"/>
+          </p:cNvPicPr>
+          <p:nvPr/>
+        </p:nvPicPr>
+        <p:blipFill>
+          <a:blip r:embed="rId3"/>
+          <a:stretch>
+            <a:fillRect/>
+          </a:stretch>
+        </p:blipFill>
+        <p:spPr>
+          <a:xfrm>
+            <a:off x="7251192" y="1627632"/>
+            <a:ext cx="2834640" cy="2834640"/>
+          </a:xfrm>
+          <a:prstGeom prst="rect">
+            <a:avLst/>
+          </a:prstGeom>
+        </p:spPr>
+      </p:pic>
+      <p:sp>
+        <p:nvSpPr>
+          <p:cNvPr id="11" name="Text 6"/>
+          <p:cNvSpPr/>
+          <p:nvPr/>
+        </p:nvSpPr>
+        <p:spPr>
+          <a:xfrm>
+            <a:off x="6565392" y="4553712"/>
+            <a:ext cx="4206240" cy="365760"/>
+          </a:xfrm>
+          <a:prstGeom prst="rect">
+            <a:avLst/>
+          </a:prstGeom>
+          <a:noFill/>
+          <a:ln/>
+        </p:spPr>
+        <p:txBody>
+          <a:bodyPr wrap="square" rtlCol="0" anchor="ctr"/>
+          <a:lstStyle/>
+          <a:p>
+            <a:pPr algn="ctr" indent="0" marL="0">
+              <a:buNone/>
+            </a:pPr>
+            <a:r>
+              <a:rPr lang="en-US" sz="1800" b="1" dirty="0">
+                <a:solidFill>
+                  <a:srgbClr val="151515"/>
+                </a:solidFill>
+                <a:latin typeface="Overpass" pitchFamily="34" charset="0"/>
+                <a:ea typeface="Overpass" pitchFamily="34" charset="-122"/>
+                <a:cs typeface="Overpass" pitchFamily="34" charset="-120"/>
+              </a:rPr>
+              <a:t>Workshops &amp; Tutorials</a:t>
+            </a:r>
+            <a:endParaRPr lang="en-US" sz="1800" dirty="0"/>
+          </a:p>
+        </p:txBody>
+      </p:sp>
+      <p:sp>
+        <p:nvSpPr>
+          <p:cNvPr id="12" name="Text 7"/>
+          <p:cNvSpPr/>
+          <p:nvPr/>
+        </p:nvSpPr>
+        <p:spPr>
+          <a:xfrm>
+            <a:off x="6473952" y="4937760"/>
+            <a:ext cx="4389120" cy="658368"/>
+          </a:xfrm>
+          <a:prstGeom prst="rect">
+            <a:avLst/>
+          </a:prstGeom>
+          <a:noFill/>
+          <a:ln/>
+        </p:spPr>
+        <p:txBody>
+          <a:bodyPr wrap="square" rtlCol="0" anchor="t"/>
+          <a:lstStyle/>
+          <a:p>
+            <a:pPr algn="ctr" indent="0" marL="0">
+              <a:buNone/>
+            </a:pPr>
+            <a:r>
+              <a:rPr lang="en-US" sz="1300" i="1" dirty="0">
+                <a:solidFill>
+                  <a:srgbClr val="5A5A5A"/>
+                </a:solidFill>
+                <a:latin typeface="Red Hat Text" pitchFamily="34" charset="0"/>
+                <a:ea typeface="Red Hat Text" pitchFamily="34" charset="-122"/>
+                <a:cs typeface="Red Hat Text" pitchFamily="34" charset="-120"/>
+              </a:rPr>
+              <a:t>The whole series: every workshop, tutorial, and deck in one place</a:t>
+            </a:r>
+            <a:endParaRPr lang="en-US" sz="1300" dirty="0"/>
+          </a:p>
+        </p:txBody>
+      </p:sp>
+      <p:sp>
+        <p:nvSpPr>
+          <p:cNvPr id="13" name="Text 8"/>
+          <p:cNvSpPr/>
+          <p:nvPr/>
+        </p:nvSpPr>
+        <p:spPr>
+          <a:xfrm>
+            <a:off x="6473952" y="5596128"/>
+            <a:ext cx="4389120" cy="292608"/>
+          </a:xfrm>
+          <a:prstGeom prst="rect">
+            <a:avLst/>
+          </a:prstGeom>
+          <a:noFill/>
+          <a:ln/>
+        </p:spPr>
+        <p:txBody>
+          <a:bodyPr wrap="square" rtlCol="0" anchor="ctr"/>
+          <a:lstStyle/>
+          <a:p>
+            <a:pPr algn="ctr" indent="0" marL="0">
+              <a:buNone/>
+            </a:pPr>
+            <a:r>
+              <a:rPr lang="en-US" sz="900" dirty="0">
+                <a:solidFill>
+                  <a:srgbClr val="EE0000"/>
+                </a:solidFill>
+                <a:latin typeface="Red Hat Mono" pitchFamily="34" charset="0"/>
+                <a:ea typeface="Red Hat Mono" pitchFamily="34" charset="-122"/>
+                <a:cs typeface="Red Hat Mono" pitchFamily="34" charset="-120"/>
+              </a:rPr>
+              <a:t>patterncatalyst.github.io/patterncatalyst-workshops-tutorials-list</a:t>
+            </a:r>
+            <a:endParaRPr lang="en-US" sz="900" dirty="0"/>
+          </a:p>
+        </p:txBody>
+      </p:sp>
+    </p:spTree>
+  </p:cSld>
+  <p:clrMapOvr>
+    <a:masterClrMapping/>
+  </p:clrMapOvr>
+</p:sld>
+</file>
+
 <file path=ppt/slides/slide3.xml><?xml version="1.0" encoding="utf-8"?>
 <p:sld xmlns:a="http://schemas.openxmlformats.org/drawingml/2006/main" xmlns:r="http://schemas.openxmlformats.org/officeDocument/2006/relationships" xmlns:p="http://schemas.openxmlformats.org/presentationml/2006/main">
   <p:cSld name="Slide 3">

</xml_diff>